<commit_message>
Comprime imagens de layout do dashboard
</commit_message>
<xml_diff>
--- a/images/layouts/paginas-portal-b2b.pptx
+++ b/images/layouts/paginas-portal-b2b.pptx
@@ -264,7 +264,7 @@
           <a:p>
             <a:fld id="{FD2AC91C-EB0E-495C-912B-3C8A99BFE46B}" type="datetimeFigureOut">
               <a:rPr lang="pt-BR" smtClean="0"/>
-              <a:t>09/08/2026</a:t>
+              <a:t>13/08/2026</a:t>
             </a:fld>
             <a:endParaRPr lang="pt-BR"/>
           </a:p>
@@ -462,7 +462,7 @@
           <a:p>
             <a:fld id="{FD2AC91C-EB0E-495C-912B-3C8A99BFE46B}" type="datetimeFigureOut">
               <a:rPr lang="pt-BR" smtClean="0"/>
-              <a:t>09/08/2026</a:t>
+              <a:t>13/08/2026</a:t>
             </a:fld>
             <a:endParaRPr lang="pt-BR"/>
           </a:p>
@@ -670,7 +670,7 @@
           <a:p>
             <a:fld id="{FD2AC91C-EB0E-495C-912B-3C8A99BFE46B}" type="datetimeFigureOut">
               <a:rPr lang="pt-BR" smtClean="0"/>
-              <a:t>09/08/2026</a:t>
+              <a:t>13/08/2026</a:t>
             </a:fld>
             <a:endParaRPr lang="pt-BR"/>
           </a:p>
@@ -868,7 +868,7 @@
           <a:p>
             <a:fld id="{FD2AC91C-EB0E-495C-912B-3C8A99BFE46B}" type="datetimeFigureOut">
               <a:rPr lang="pt-BR" smtClean="0"/>
-              <a:t>09/08/2026</a:t>
+              <a:t>13/08/2026</a:t>
             </a:fld>
             <a:endParaRPr lang="pt-BR"/>
           </a:p>
@@ -1143,7 +1143,7 @@
           <a:p>
             <a:fld id="{FD2AC91C-EB0E-495C-912B-3C8A99BFE46B}" type="datetimeFigureOut">
               <a:rPr lang="pt-BR" smtClean="0"/>
-              <a:t>09/08/2026</a:t>
+              <a:t>13/08/2026</a:t>
             </a:fld>
             <a:endParaRPr lang="pt-BR"/>
           </a:p>
@@ -1408,7 +1408,7 @@
           <a:p>
             <a:fld id="{FD2AC91C-EB0E-495C-912B-3C8A99BFE46B}" type="datetimeFigureOut">
               <a:rPr lang="pt-BR" smtClean="0"/>
-              <a:t>09/08/2026</a:t>
+              <a:t>13/08/2026</a:t>
             </a:fld>
             <a:endParaRPr lang="pt-BR"/>
           </a:p>
@@ -1820,7 +1820,7 @@
           <a:p>
             <a:fld id="{FD2AC91C-EB0E-495C-912B-3C8A99BFE46B}" type="datetimeFigureOut">
               <a:rPr lang="pt-BR" smtClean="0"/>
-              <a:t>09/08/2026</a:t>
+              <a:t>13/08/2026</a:t>
             </a:fld>
             <a:endParaRPr lang="pt-BR"/>
           </a:p>
@@ -1961,7 +1961,7 @@
           <a:p>
             <a:fld id="{FD2AC91C-EB0E-495C-912B-3C8A99BFE46B}" type="datetimeFigureOut">
               <a:rPr lang="pt-BR" smtClean="0"/>
-              <a:t>09/08/2026</a:t>
+              <a:t>13/08/2026</a:t>
             </a:fld>
             <a:endParaRPr lang="pt-BR"/>
           </a:p>
@@ -2074,7 +2074,7 @@
           <a:p>
             <a:fld id="{FD2AC91C-EB0E-495C-912B-3C8A99BFE46B}" type="datetimeFigureOut">
               <a:rPr lang="pt-BR" smtClean="0"/>
-              <a:t>09/08/2026</a:t>
+              <a:t>13/08/2026</a:t>
             </a:fld>
             <a:endParaRPr lang="pt-BR"/>
           </a:p>
@@ -2385,7 +2385,7 @@
           <a:p>
             <a:fld id="{FD2AC91C-EB0E-495C-912B-3C8A99BFE46B}" type="datetimeFigureOut">
               <a:rPr lang="pt-BR" smtClean="0"/>
-              <a:t>09/08/2026</a:t>
+              <a:t>13/08/2026</a:t>
             </a:fld>
             <a:endParaRPr lang="pt-BR"/>
           </a:p>
@@ -2673,7 +2673,7 @@
           <a:p>
             <a:fld id="{FD2AC91C-EB0E-495C-912B-3C8A99BFE46B}" type="datetimeFigureOut">
               <a:rPr lang="pt-BR" smtClean="0"/>
-              <a:t>09/08/2026</a:t>
+              <a:t>13/08/2026</a:t>
             </a:fld>
             <a:endParaRPr lang="pt-BR"/>
           </a:p>
@@ -2914,7 +2914,7 @@
           <a:p>
             <a:fld id="{FD2AC91C-EB0E-495C-912B-3C8A99BFE46B}" type="datetimeFigureOut">
               <a:rPr lang="pt-BR" smtClean="0"/>
-              <a:t>09/08/2026</a:t>
+              <a:t>13/08/2026</a:t>
             </a:fld>
             <a:endParaRPr lang="pt-BR"/>
           </a:p>
@@ -4759,7 +4759,7 @@
         <p:spPr>
           <a:xfrm>
             <a:off x="2290225" y="2237216"/>
-            <a:ext cx="4648486" cy="347472"/>
+            <a:ext cx="4648486" cy="241200"/>
           </a:xfrm>
           <a:prstGeom prst="round2SameRect">
             <a:avLst/>
@@ -4809,7 +4809,7 @@
         <p:spPr>
           <a:xfrm>
             <a:off x="7241107" y="2227995"/>
-            <a:ext cx="4648486" cy="347472"/>
+            <a:ext cx="4648486" cy="241200"/>
           </a:xfrm>
           <a:prstGeom prst="round2SameRect">
             <a:avLst/>
@@ -4859,7 +4859,7 @@
         <p:spPr>
           <a:xfrm>
             <a:off x="2282703" y="4547607"/>
-            <a:ext cx="9599377" cy="347472"/>
+            <a:ext cx="9599377" cy="241200"/>
           </a:xfrm>
           <a:prstGeom prst="round2SameRect">
             <a:avLst/>
@@ -4908,7 +4908,7 @@
         </p:nvSpPr>
         <p:spPr>
           <a:xfrm>
-            <a:off x="3504432" y="2268226"/>
+            <a:off x="3504432" y="2227995"/>
             <a:ext cx="2220072" cy="292388"/>
           </a:xfrm>
           <a:prstGeom prst="rect">
@@ -4929,39 +4929,17 @@
                 </a:solidFill>
                 <a:latin typeface="Avenir Next W1G Medium" panose="020B0603020202020204" pitchFamily="34" charset="0"/>
               </a:rPr>
-              <a:t>Situação da Base do Portal</a:t>
+              <a:t>Situação da </a:t>
             </a:r>
-          </a:p>
-        </p:txBody>
-      </p:sp>
-      <p:sp>
-        <p:nvSpPr>
-          <p:cNvPr id="39" name="CaixaDeTexto 38">
-            <a:extLst>
-              <a:ext uri="{FF2B5EF4-FFF2-40B4-BE49-F238E27FC236}">
-                <a16:creationId xmlns:a16="http://schemas.microsoft.com/office/drawing/2014/main" id="{8A724EA4-0A02-4DBA-FD84-25A4C608FBA0}"/>
-              </a:ext>
-            </a:extLst>
-          </p:cNvPr>
-          <p:cNvSpPr txBox="1"/>
-          <p:nvPr/>
-        </p:nvSpPr>
-        <p:spPr>
-          <a:xfrm>
-            <a:off x="8295884" y="2246453"/>
-            <a:ext cx="2538933" cy="292388"/>
-          </a:xfrm>
-          <a:prstGeom prst="rect">
-            <a:avLst/>
-          </a:prstGeom>
-          <a:noFill/>
-        </p:spPr>
-        <p:txBody>
-          <a:bodyPr wrap="square" rtlCol="0">
-            <a:spAutoFit/>
-          </a:bodyPr>
-          <a:lstStyle/>
-          <a:p>
+            <a:r>
+              <a:rPr lang="pt-BR" sz="1200" dirty="0">
+                <a:solidFill>
+                  <a:schemeClr val="bg1"/>
+                </a:solidFill>
+                <a:latin typeface="Avenir Next W1G Medium" panose="020B0603020202020204" pitchFamily="34" charset="0"/>
+              </a:rPr>
+              <a:t>Base</a:t>
+            </a:r>
             <a:r>
               <a:rPr lang="pt-BR" sz="1300" dirty="0">
                 <a:solidFill>
@@ -4969,17 +4947,17 @@
                 </a:solidFill>
                 <a:latin typeface="Avenir Next W1G Medium" panose="020B0603020202020204" pitchFamily="34" charset="0"/>
               </a:rPr>
-              <a:t>Funil de Adoção do Portal B2B</a:t>
+              <a:t> do Portal</a:t>
             </a:r>
           </a:p>
         </p:txBody>
       </p:sp>
       <p:sp>
         <p:nvSpPr>
-          <p:cNvPr id="40" name="CaixaDeTexto 39">
-            <a:extLst>
-              <a:ext uri="{FF2B5EF4-FFF2-40B4-BE49-F238E27FC236}">
-                <a16:creationId xmlns:a16="http://schemas.microsoft.com/office/drawing/2014/main" id="{763B639C-CFD6-114D-3E03-37F9BE924766}"/>
+          <p:cNvPr id="39" name="CaixaDeTexto 38">
+            <a:extLst>
+              <a:ext uri="{FF2B5EF4-FFF2-40B4-BE49-F238E27FC236}">
+                <a16:creationId xmlns:a16="http://schemas.microsoft.com/office/drawing/2014/main" id="{8A724EA4-0A02-4DBA-FD84-25A4C608FBA0}"/>
               </a:ext>
             </a:extLst>
           </p:cNvPr>
@@ -4988,8 +4966,8 @@
         </p:nvSpPr>
         <p:spPr>
           <a:xfrm>
-            <a:off x="6008663" y="4578298"/>
-            <a:ext cx="2147456" cy="292388"/>
+            <a:off x="8295884" y="2216196"/>
+            <a:ext cx="2538933" cy="276999"/>
           </a:xfrm>
           <a:prstGeom prst="rect">
             <a:avLst/>
@@ -5003,13 +4981,53 @@
           <a:lstStyle/>
           <a:p>
             <a:r>
-              <a:rPr lang="pt-BR" sz="1300" dirty="0">
+              <a:rPr lang="pt-BR" sz="1200" dirty="0">
                 <a:solidFill>
                   <a:schemeClr val="bg1"/>
                 </a:solidFill>
                 <a:latin typeface="Avenir Next W1G Medium" panose="020B0603020202020204" pitchFamily="34" charset="0"/>
               </a:rPr>
-              <a:t>Vendas do Portal por Mês</a:t>
+              <a:t>Funil de Adoção do Portal B2B</a:t>
+            </a:r>
+          </a:p>
+        </p:txBody>
+      </p:sp>
+      <p:sp>
+        <p:nvSpPr>
+          <p:cNvPr id="40" name="CaixaDeTexto 39">
+            <a:extLst>
+              <a:ext uri="{FF2B5EF4-FFF2-40B4-BE49-F238E27FC236}">
+                <a16:creationId xmlns:a16="http://schemas.microsoft.com/office/drawing/2014/main" id="{763B639C-CFD6-114D-3E03-37F9BE924766}"/>
+              </a:ext>
+            </a:extLst>
+          </p:cNvPr>
+          <p:cNvSpPr txBox="1"/>
+          <p:nvPr/>
+        </p:nvSpPr>
+        <p:spPr>
+          <a:xfrm>
+            <a:off x="6008663" y="4532435"/>
+            <a:ext cx="2147456" cy="276999"/>
+          </a:xfrm>
+          <a:prstGeom prst="rect">
+            <a:avLst/>
+          </a:prstGeom>
+          <a:noFill/>
+        </p:spPr>
+        <p:txBody>
+          <a:bodyPr wrap="square" rtlCol="0">
+            <a:spAutoFit/>
+          </a:bodyPr>
+          <a:lstStyle/>
+          <a:p>
+            <a:r>
+              <a:rPr lang="pt-BR" sz="1200" dirty="0">
+                <a:solidFill>
+                  <a:schemeClr val="bg1"/>
+                </a:solidFill>
+                <a:latin typeface="Avenir Next W1G Medium" panose="020B0603020202020204" pitchFamily="34" charset="0"/>
+              </a:rPr>
+              <a:t>Vendas do Portal por mês</a:t>
             </a:r>
           </a:p>
         </p:txBody>
@@ -5579,7 +5597,7 @@
         </p:nvSpPr>
         <p:spPr>
           <a:xfrm rot="16200000">
-            <a:off x="3660917" y="-1673090"/>
+            <a:off x="3660917" y="-1667266"/>
             <a:ext cx="6857998" cy="10204179"/>
           </a:xfrm>
           <a:prstGeom prst="round2SameRect">
@@ -6388,7 +6406,7 @@
           </a:xfrm>
           <a:prstGeom prst="roundRect">
             <a:avLst>
-              <a:gd name="adj" fmla="val 11302"/>
+              <a:gd name="adj" fmla="val 7121"/>
             </a:avLst>
           </a:prstGeom>
           <a:solidFill>
@@ -6508,7 +6526,7 @@
         <p:spPr>
           <a:xfrm>
             <a:off x="2290225" y="2237216"/>
-            <a:ext cx="4648486" cy="347472"/>
+            <a:ext cx="4648486" cy="241200"/>
           </a:xfrm>
           <a:prstGeom prst="round2SameRect">
             <a:avLst/>
@@ -6557,8 +6575,8 @@
         </p:nvSpPr>
         <p:spPr>
           <a:xfrm>
-            <a:off x="2718478" y="2268226"/>
-            <a:ext cx="3791981" cy="292388"/>
+            <a:off x="2718478" y="2227995"/>
+            <a:ext cx="3791981" cy="276999"/>
           </a:xfrm>
           <a:prstGeom prst="rect">
             <a:avLst/>
@@ -6572,7 +6590,7 @@
           <a:lstStyle/>
           <a:p>
             <a:r>
-              <a:rPr lang="pt-BR" sz="1300" dirty="0">
+              <a:rPr lang="pt-BR" sz="1200" dirty="0">
                 <a:solidFill>
                   <a:schemeClr val="bg1"/>
                 </a:solidFill>
@@ -6602,7 +6620,7 @@
           </a:xfrm>
           <a:prstGeom prst="roundRect">
             <a:avLst>
-              <a:gd name="adj" fmla="val 11302"/>
+              <a:gd name="adj" fmla="val 13622"/>
             </a:avLst>
           </a:prstGeom>
           <a:solidFill>
@@ -6659,8 +6677,8 @@
         </p:nvSpPr>
         <p:spPr>
           <a:xfrm>
-            <a:off x="7241107" y="4546800"/>
-            <a:ext cx="4648486" cy="347472"/>
+            <a:off x="7252755" y="4546800"/>
+            <a:ext cx="4648486" cy="241200"/>
           </a:xfrm>
           <a:prstGeom prst="round2SameRect">
             <a:avLst/>
@@ -6710,7 +6728,7 @@
         <p:spPr>
           <a:xfrm>
             <a:off x="7241107" y="2227995"/>
-            <a:ext cx="4648486" cy="347472"/>
+            <a:ext cx="4648486" cy="241200"/>
           </a:xfrm>
           <a:prstGeom prst="round2SameRect">
             <a:avLst/>
@@ -6759,8 +6777,8 @@
         </p:nvSpPr>
         <p:spPr>
           <a:xfrm>
-            <a:off x="8295560" y="2246400"/>
-            <a:ext cx="2539581" cy="292388"/>
+            <a:off x="8295560" y="2211450"/>
+            <a:ext cx="2539581" cy="276999"/>
           </a:xfrm>
           <a:prstGeom prst="rect">
             <a:avLst/>
@@ -6774,7 +6792,7 @@
           <a:lstStyle/>
           <a:p>
             <a:r>
-              <a:rPr lang="pt-BR" sz="1300" dirty="0">
+              <a:rPr lang="pt-BR" sz="1200" dirty="0">
                 <a:solidFill>
                   <a:schemeClr val="bg1"/>
                 </a:solidFill>
@@ -6889,8 +6907,8 @@
         </p:nvSpPr>
         <p:spPr>
           <a:xfrm>
-            <a:off x="7755583" y="4579200"/>
-            <a:ext cx="3619535" cy="292388"/>
+            <a:off x="7755583" y="4540797"/>
+            <a:ext cx="3619535" cy="276999"/>
           </a:xfrm>
           <a:prstGeom prst="rect">
             <a:avLst/>
@@ -6904,7 +6922,7 @@
           <a:lstStyle/>
           <a:p>
             <a:r>
-              <a:rPr lang="pt-BR" sz="1300" dirty="0">
+              <a:rPr lang="pt-BR" sz="1200" dirty="0">
                 <a:solidFill>
                   <a:schemeClr val="bg1"/>
                 </a:solidFill>
@@ -8628,7 +8646,7 @@
           </a:xfrm>
           <a:prstGeom prst="roundRect">
             <a:avLst>
-              <a:gd name="adj" fmla="val 11302"/>
+              <a:gd name="adj" fmla="val 14202"/>
             </a:avLst>
           </a:prstGeom>
           <a:solidFill>
@@ -8685,8 +8703,8 @@
         </p:nvSpPr>
         <p:spPr>
           <a:xfrm>
-            <a:off x="7241107" y="4546800"/>
-            <a:ext cx="4648486" cy="347472"/>
+            <a:off x="7252755" y="4546800"/>
+            <a:ext cx="4648486" cy="241200"/>
           </a:xfrm>
           <a:prstGeom prst="round2SameRect">
             <a:avLst/>
@@ -8736,7 +8754,7 @@
         <p:spPr>
           <a:xfrm>
             <a:off x="7241107" y="2227995"/>
-            <a:ext cx="4648486" cy="347472"/>
+            <a:ext cx="4648486" cy="241200"/>
           </a:xfrm>
           <a:prstGeom prst="round2SameRect">
             <a:avLst/>
@@ -8785,8 +8803,8 @@
         </p:nvSpPr>
         <p:spPr>
           <a:xfrm>
-            <a:off x="8109039" y="2246400"/>
-            <a:ext cx="2912622" cy="292388"/>
+            <a:off x="8109039" y="2223399"/>
+            <a:ext cx="2912622" cy="276999"/>
           </a:xfrm>
           <a:prstGeom prst="rect">
             <a:avLst/>
@@ -8800,7 +8818,7 @@
           <a:lstStyle/>
           <a:p>
             <a:r>
-              <a:rPr lang="pt-BR" sz="1300" dirty="0">
+              <a:rPr lang="pt-BR" sz="1200" dirty="0">
                 <a:solidFill>
                   <a:schemeClr val="bg1"/>
                 </a:solidFill>
@@ -8879,8 +8897,8 @@
         </p:nvSpPr>
         <p:spPr>
           <a:xfrm>
-            <a:off x="8492345" y="4579200"/>
-            <a:ext cx="2146011" cy="292388"/>
+            <a:off x="8365892" y="4530702"/>
+            <a:ext cx="2398916" cy="276999"/>
           </a:xfrm>
           <a:prstGeom prst="rect">
             <a:avLst/>
@@ -8894,13 +8912,13 @@
           <a:lstStyle/>
           <a:p>
             <a:r>
-              <a:rPr lang="pt-BR" sz="1300" dirty="0">
+              <a:rPr lang="pt-BR" sz="1200" dirty="0">
                 <a:solidFill>
                   <a:schemeClr val="bg1"/>
                 </a:solidFill>
                 <a:latin typeface="Avenir Next W1G Medium" panose="020B0603020202020204" pitchFamily="34" charset="0"/>
               </a:rPr>
-              <a:t>Mix por Grupo de Cliente</a:t>
+              <a:t>Compradores Mensais Portal</a:t>
             </a:r>
           </a:p>
         </p:txBody>
@@ -9036,7 +9054,7 @@
         <p:spPr>
           <a:xfrm>
             <a:off x="2290225" y="4546800"/>
-            <a:ext cx="4648486" cy="347472"/>
+            <a:ext cx="4648486" cy="241200"/>
           </a:xfrm>
           <a:prstGeom prst="round2SameRect">
             <a:avLst/>
@@ -9085,8 +9103,8 @@
         </p:nvSpPr>
         <p:spPr>
           <a:xfrm>
-            <a:off x="2797424" y="4588332"/>
-            <a:ext cx="3634088" cy="292388"/>
+            <a:off x="2797424" y="4530702"/>
+            <a:ext cx="3634088" cy="276999"/>
           </a:xfrm>
           <a:prstGeom prst="rect">
             <a:avLst/>
@@ -9100,7 +9118,7 @@
           <a:lstStyle/>
           <a:p>
             <a:r>
-              <a:rPr lang="pt-BR" sz="1300" dirty="0">
+              <a:rPr lang="pt-BR" sz="1200" dirty="0">
                 <a:solidFill>
                   <a:schemeClr val="bg1"/>
                 </a:solidFill>
@@ -9188,7 +9206,7 @@
         <p:spPr>
           <a:xfrm>
             <a:off x="2290225" y="2237216"/>
-            <a:ext cx="4648486" cy="347472"/>
+            <a:ext cx="4648486" cy="240202"/>
           </a:xfrm>
           <a:prstGeom prst="round2SameRect">
             <a:avLst/>
@@ -9237,8 +9255,8 @@
         </p:nvSpPr>
         <p:spPr>
           <a:xfrm>
-            <a:off x="3524473" y="2268226"/>
-            <a:ext cx="2179991" cy="292388"/>
+            <a:off x="3524473" y="2225482"/>
+            <a:ext cx="2179991" cy="276999"/>
           </a:xfrm>
           <a:prstGeom prst="rect">
             <a:avLst/>
@@ -9252,7 +9270,7 @@
           <a:lstStyle/>
           <a:p>
             <a:r>
-              <a:rPr lang="pt-BR" sz="1300" dirty="0">
+              <a:rPr lang="pt-BR" sz="1200" dirty="0">
                 <a:solidFill>
                   <a:schemeClr val="bg1"/>
                 </a:solidFill>
@@ -10852,7 +10870,7 @@
         <p:spPr>
           <a:xfrm>
             <a:off x="2282703" y="4547607"/>
-            <a:ext cx="9599377" cy="347472"/>
+            <a:ext cx="9599377" cy="241200"/>
           </a:xfrm>
           <a:prstGeom prst="round2SameRect">
             <a:avLst/>
@@ -10901,8 +10919,8 @@
         </p:nvSpPr>
         <p:spPr>
           <a:xfrm>
-            <a:off x="6001623" y="4578298"/>
-            <a:ext cx="2161536" cy="292388"/>
+            <a:off x="6001623" y="4529707"/>
+            <a:ext cx="2161536" cy="276999"/>
           </a:xfrm>
           <a:prstGeom prst="rect">
             <a:avLst/>
@@ -10916,7 +10934,7 @@
           <a:lstStyle/>
           <a:p>
             <a:r>
-              <a:rPr lang="pt-BR" sz="1300" dirty="0">
+              <a:rPr lang="pt-BR" sz="1200" dirty="0">
                 <a:solidFill>
                   <a:schemeClr val="bg1"/>
                 </a:solidFill>
@@ -11004,7 +11022,7 @@
         <p:spPr>
           <a:xfrm>
             <a:off x="2271219" y="2109284"/>
-            <a:ext cx="9599377" cy="347472"/>
+            <a:ext cx="9599377" cy="241200"/>
           </a:xfrm>
           <a:prstGeom prst="round2SameRect">
             <a:avLst/>
@@ -11053,8 +11071,8 @@
         </p:nvSpPr>
         <p:spPr>
           <a:xfrm>
-            <a:off x="5330521" y="2146299"/>
-            <a:ext cx="3480773" cy="307777"/>
+            <a:off x="5330521" y="2104591"/>
+            <a:ext cx="3480773" cy="276999"/>
           </a:xfrm>
           <a:prstGeom prst="rect">
             <a:avLst/>
@@ -11068,16 +11086,16 @@
           <a:lstStyle/>
           <a:p>
             <a:r>
-              <a:rPr lang="pt-BR" sz="1300" dirty="0">
+              <a:rPr lang="pt-BR" sz="1200" dirty="0">
                 <a:solidFill>
                   <a:schemeClr val="bg1"/>
                 </a:solidFill>
                 <a:latin typeface="Avenir Next W1G Medium" panose="020B0603020202020204" pitchFamily="34" charset="0"/>
               </a:rPr>
-              <a:t>Vendas por Mês </a:t>
+              <a:t>Vendas por mês </a:t>
             </a:r>
             <a:r>
-              <a:rPr lang="pt-BR" sz="1400" b="1" dirty="0">
+              <a:rPr lang="pt-BR" sz="1200" b="1" dirty="0">
                 <a:solidFill>
                   <a:schemeClr val="bg1"/>
                 </a:solidFill>
@@ -11086,7 +11104,7 @@
               <a:t>—</a:t>
             </a:r>
             <a:r>
-              <a:rPr lang="pt-BR" sz="1400" b="1" dirty="0">
+              <a:rPr lang="pt-BR" sz="1200" b="1" dirty="0">
                 <a:solidFill>
                   <a:schemeClr val="bg1"/>
                 </a:solidFill>
@@ -11095,13 +11113,13 @@
               <a:t> </a:t>
             </a:r>
             <a:r>
-              <a:rPr lang="pt-BR" sz="1300" dirty="0">
+              <a:rPr lang="pt-BR" sz="1200" dirty="0">
                 <a:solidFill>
                   <a:schemeClr val="bg1"/>
                 </a:solidFill>
                 <a:latin typeface="Avenir Next W1G Medium" panose="020B0603020202020204" pitchFamily="34" charset="0"/>
               </a:rPr>
-              <a:t>Comparação Entre Anos</a:t>
+              <a:t>Comparação entre Anos</a:t>
             </a:r>
           </a:p>
         </p:txBody>
@@ -11183,7 +11201,7 @@
         <p:spPr>
           <a:xfrm>
             <a:off x="2278311" y="912706"/>
-            <a:ext cx="9599377" cy="347472"/>
+            <a:ext cx="9599377" cy="241200"/>
           </a:xfrm>
           <a:prstGeom prst="round2SameRect">
             <a:avLst/>
@@ -11232,8 +11250,8 @@
         </p:nvSpPr>
         <p:spPr>
           <a:xfrm>
-            <a:off x="6162086" y="929897"/>
-            <a:ext cx="1831826" cy="292388"/>
+            <a:off x="6162086" y="894887"/>
+            <a:ext cx="1831826" cy="276999"/>
           </a:xfrm>
           <a:prstGeom prst="rect">
             <a:avLst/>
@@ -11247,7 +11265,7 @@
           <a:lstStyle/>
           <a:p>
             <a:r>
-              <a:rPr lang="pt-BR" sz="1300" dirty="0">
+              <a:rPr lang="pt-BR" sz="1200" dirty="0">
                 <a:solidFill>
                   <a:schemeClr val="bg1"/>
                 </a:solidFill>
@@ -12815,7 +12833,7 @@
           </a:xfrm>
           <a:prstGeom prst="roundRect">
             <a:avLst>
-              <a:gd name="adj" fmla="val 11302"/>
+              <a:gd name="adj" fmla="val 7929"/>
             </a:avLst>
           </a:prstGeom>
           <a:solidFill>
@@ -12873,7 +12891,7 @@
         <p:spPr>
           <a:xfrm>
             <a:off x="2301873" y="2235600"/>
-            <a:ext cx="9580207" cy="347472"/>
+            <a:ext cx="9580207" cy="241200"/>
           </a:xfrm>
           <a:prstGeom prst="round2SameRect">
             <a:avLst/>
@@ -13217,8 +13235,8 @@
         </p:nvSpPr>
         <p:spPr>
           <a:xfrm>
-            <a:off x="6000841" y="2262867"/>
-            <a:ext cx="2182271" cy="292388"/>
+            <a:off x="5727156" y="2216196"/>
+            <a:ext cx="2729641" cy="276999"/>
           </a:xfrm>
           <a:prstGeom prst="rect">
             <a:avLst/>
@@ -13232,13 +13250,13 @@
           <a:lstStyle/>
           <a:p>
             <a:r>
-              <a:rPr lang="pt-BR" sz="1300" dirty="0">
+              <a:rPr lang="pt-BR" sz="1200" dirty="0">
                 <a:solidFill>
                   <a:schemeClr val="bg1"/>
                 </a:solidFill>
                 <a:latin typeface="Avenir Next W1G Medium" panose="020B0603020202020204" pitchFamily="34" charset="0"/>
               </a:rPr>
-              <a:t>Plano de Ação por Cliente</a:t>
+              <a:t>Plano de Ação por Cliente do Portal</a:t>
             </a:r>
           </a:p>
         </p:txBody>

</xml_diff>